<commit_message>
feat: add source files and documentation links for MSP TP to index page
</commit_message>
<xml_diff>
--- a/OI/TQ_2026 CQPM Technicien qualité - Bourges 5-6 Novembre  2026/Capabilite_SPC_Formation_2jours.pptx
+++ b/OI/TQ_2026 CQPM Technicien qualité - Bourges 5-6 Novembre  2026/Capabilite_SPC_Formation_2jours.pptx
@@ -7108,7 +7108,7 @@
                 <a:ea typeface="Calibri" pitchFamily="34" charset="-122"/>
                 <a:cs typeface="Calibri" pitchFamily="34" charset="-120"/>
               </a:rPr>
-              <a:t>Li = 22,00 mm</a:t>
+              <a:t>Li = 11,80 mm</a:t>
             </a:r>
             <a:endParaRPr lang="en-US" sz="1200" dirty="0"/>
           </a:p>
@@ -7147,7 +7147,7 @@
                 <a:ea typeface="Calibri" pitchFamily="34" charset="-122"/>
                 <a:cs typeface="Calibri" pitchFamily="34" charset="-120"/>
               </a:rPr>
-              <a:t>Ls = 22,40 mm</a:t>
+              <a:t>Ls = 11,96 mm</a:t>
             </a:r>
             <a:endParaRPr lang="en-US" sz="1200" dirty="0"/>
           </a:p>
@@ -7186,7 +7186,7 @@
                 <a:ea typeface="Calibri" pitchFamily="34" charset="-122"/>
                 <a:cs typeface="Calibri" pitchFamily="34" charset="-120"/>
               </a:rPr>
-              <a:t>Cible = 22,20 mm</a:t>
+              <a:t>Cible = 11,88 mm</a:t>
             </a:r>
             <a:endParaRPr lang="en-US" sz="1200" dirty="0"/>
           </a:p>

</xml_diff>

<commit_message>
Please provide the diff or the list of changes you would like summarized.
</commit_message>
<xml_diff>
--- a/OI/TQ_2026 CQPM Technicien qualité - Bourges 5-6 Novembre  2026/Capabilite_SPC_Formation_2jours.pptx
+++ b/OI/TQ_2026 CQPM Technicien qualité - Bourges 5-6 Novembre  2026/Capabilite_SPC_Formation_2jours.pptx
@@ -144,7 +144,7 @@
   <pc:docChgLst>
     <pc:chgData name="Stéphane JAUBERT" userId="926aeaf5-0d8d-4569-9635-338e3b4850fc" providerId="ADAL" clId="{C777CAD2-2948-4130-A6C6-8CB11CD7CD00}"/>
     <pc:docChg chg="modSld">
-      <pc:chgData name="Stéphane JAUBERT" userId="926aeaf5-0d8d-4569-9635-338e3b4850fc" providerId="ADAL" clId="{C777CAD2-2948-4130-A6C6-8CB11CD7CD00}" dt="2026-07-20T13:51:12.180" v="1" actId="14100"/>
+      <pc:chgData name="Stéphane JAUBERT" userId="926aeaf5-0d8d-4569-9635-338e3b4850fc" providerId="ADAL" clId="{C777CAD2-2948-4130-A6C6-8CB11CD7CD00}" dt="2026-07-22T13:15:57.420" v="2" actId="14100"/>
       <pc:docMkLst>
         <pc:docMk/>
       </pc:docMkLst>
@@ -159,6 +159,21 @@
           <ac:picMkLst>
             <pc:docMk/>
             <pc:sldMk cId="0" sldId="256"/>
+            <ac:picMk id="9" creationId="{00000000-0000-0000-0000-000000000000}"/>
+          </ac:picMkLst>
+        </pc:picChg>
+      </pc:sldChg>
+      <pc:sldChg chg="modSp mod">
+        <pc:chgData name="Stéphane JAUBERT" userId="926aeaf5-0d8d-4569-9635-338e3b4850fc" providerId="ADAL" clId="{C777CAD2-2948-4130-A6C6-8CB11CD7CD00}" dt="2026-07-22T13:15:57.420" v="2" actId="14100"/>
+        <pc:sldMkLst>
+          <pc:docMk/>
+          <pc:sldMk cId="0" sldId="258"/>
+        </pc:sldMkLst>
+        <pc:picChg chg="mod">
+          <ac:chgData name="Stéphane JAUBERT" userId="926aeaf5-0d8d-4569-9635-338e3b4850fc" providerId="ADAL" clId="{C777CAD2-2948-4130-A6C6-8CB11CD7CD00}" dt="2026-07-22T13:15:57.420" v="2" actId="14100"/>
+          <ac:picMkLst>
+            <pc:docMk/>
+            <pc:sldMk cId="0" sldId="258"/>
             <ac:picMk id="9" creationId="{00000000-0000-0000-0000-000000000000}"/>
           </ac:picMkLst>
         </pc:picChg>
@@ -24332,8 +24347,8 @@
         </p:blipFill>
         <p:spPr>
           <a:xfrm>
-            <a:off x="7818120" y="4434840"/>
-            <a:ext cx="1143000" cy="658368"/>
+            <a:off x="8341688" y="4434840"/>
+            <a:ext cx="619432" cy="658368"/>
           </a:xfrm>
           <a:prstGeom prst="rect">
             <a:avLst/>

</xml_diff>